<commit_message>
EgoQuant: final snapshot of the version tagged submission-20oct (reverted report format, red-team results, on-chain evidence; 20 October 2026 17:30)
</commit_message>
<xml_diff>
--- a/submission/2_Presentation/EGOQUANT_PRESENTATION.pptx
+++ b/submission/2_Presentation/EGOQUANT_PRESENTATION.pptx
@@ -602,7 +602,7 @@
           <a:p>
             <a:r>
               <a:rPr lang="en-US" dirty="0"/>
-              <a:t>Security is thirty percent of the score, so here is what we measured. Three and a half thousand automatic tests, with hostile-input suites, property sweeps and mutation checks where we broke the code on purpose to see the tests fail. A read-only deploy check passes seventy-one of seventy-one on the live service. The dependency audit found nothing. And we list twenty-eight known gaps with owners, next to a threat table, because a limit that is written down can be defended. Users are isolated by Row-Level Security with no privileged key anywhere; data is minimal, expires, and can be erased completely.</a:t>
+              <a:t>Security is thirty percent of the score, so here is what we measured. Three and a half thousand automatic tests, 3,554 on the submitted version, with hostile-input suites, property sweeps and mutation checks where we broke the code on purpose to see the tests fail. A read-only deploy check passes seventy-one of seventy-one on the live service. The dependency audit found nothing. And we list twenty-eight known gaps with owners, next to a threat table, because a limit that is written down can be defended. Users are isolated by Row-Level Security with no privileged key anywhere; data is minimal, expires, and can be erased completely.</a:t>
             </a:r>
             <a:endParaRPr lang="en-US" dirty="0"/>
           </a:p>
@@ -2614,7 +2614,7 @@
                 <a:ea typeface="Cambria" pitchFamily="34" charset="-122"/>
                 <a:cs typeface="Cambria" pitchFamily="34" charset="-120"/>
               </a:rPr>
-              <a:t>3,540</a:t>
+              <a:t>3,554</a:t>
             </a:r>
             <a:endParaRPr lang="en-US" sz="3600" dirty="0"/>
           </a:p>
@@ -2650,7 +2650,7 @@
                   <a:srgbClr val="333333"/>
                 </a:solidFill>
               </a:rPr>
-              <a:t>automatic tests, offline: 3,538 pass, 1 failed (a timing test of the news page), 1 skipped</a:t>
+              <a:t>automatic tests, offline; last complete run 3,538 of 3,540 passed, 1 failed (a timing test of the news page), 1 skipped; 14 added since ran green</a:t>
             </a:r>
             <a:endParaRPr lang="en-US" sz="1100" dirty="0"/>
           </a:p>

</xml_diff>

<commit_message>
submission: package refreshed (deck, README and evidence index name www.egoquant.app); 20 October 2026 18:33
</commit_message>
<xml_diff>
--- a/submission/2_Presentation/EGOQUANT_PRESENTATION.pptx
+++ b/submission/2_Presentation/EGOQUANT_PRESENTATION.pptx
@@ -1130,7 +1130,7 @@
           <a:p>
             <a:r>
               <a:rPr lang="en-US" dirty="0"/>
-              <a:t>The journey takes about ten minutes. A validated questionnaire gives the risk category and its limits. A short Risk Game adds behaviour. The investor picks what they would like to hold, and only what their category allows can be ticked, with the reason shown for everything else. The portfolio is built on real prices and approved by the Risk Engine, with the chance of reaching the goal shown as N in 100 simulated futures. Finally the plan is reviewed, confirmed and sealed, and anyone can verify the sealed report later. LIVE DEMO (30 seconds, no sign-in): open fintechaton-frontend.vercel.app/verify, press Use the demo report (Unchanged, Sealed for demo_investor, block 11,951,549), then Try a tampered copy (Does not match). If asked for an operation log: the dated deploy-check file in the evidence folder (71 of 71 checks on the live service, 20 Oct) and the fourteen-investor run log (30 builds, 26 trade checks, 14 what-ifs, 0 rule failures).</a:t>
+              <a:t>The journey takes about ten minutes. A validated questionnaire gives the risk category and its limits. A short Risk Game adds behaviour. The investor picks what they would like to hold, and only what their category allows can be ticked, with the reason shown for everything else. The portfolio is built on real prices and approved by the Risk Engine, with the chance of reaching the goal shown as N in 100 simulated futures. Finally the plan is reviewed, confirmed and sealed, and anyone can verify the sealed report later. LIVE DEMO (30 seconds, no sign-in): open www.egoquant.app/verify, press Use the demo report (Unchanged, Sealed for demo_investor, block 11,951,549), then Try a tampered copy (Does not match). If asked for an operation log: the dated deploy-check file in the evidence folder (71 of 71 checks on the live service, 20 Oct) and the fourteen-investor run log (30 builds, 26 trade checks, 14 what-ifs, 0 rule failures).</a:t>
             </a:r>
             <a:endParaRPr lang="en-US" dirty="0"/>
           </a:p>
@@ -2418,7 +2418,7 @@
                   <a:srgbClr val="CFCFCF"/>
                 </a:solidFill>
               </a:rPr>
-              <a:t>Live: fintechaton-frontend.vercel.app</a:t>
+              <a:t>Live: www.egoquant.app</a:t>
             </a:r>
             <a:endParaRPr lang="en-US" sz="1300" dirty="0"/>
           </a:p>
@@ -3940,7 +3940,7 @@
                   <a:srgbClr val="E8E8E8"/>
                 </a:solidFill>
               </a:rPr>
-              <a:t>Live site: fintechaton-frontend.vercel.app · API and interactive docs: web-production-59960.up.railway.app/docs</a:t>
+              <a:t>Live site: www.egoquant.app · API and interactive docs: web-production-59960.up.railway.app/docs</a:t>
             </a:r>
             <a:endParaRPr lang="en-US" sz="1500" dirty="0"/>
           </a:p>

</xml_diff>

<commit_message>
submission: README.pdf links point to the files in the package; deck image descriptions
</commit_message>
<xml_diff>
--- a/submission/2_Presentation/EGOQUANT_PRESENTATION.pptx
+++ b/submission/2_Presentation/EGOQUANT_PRESENTATION.pptx
@@ -2426,7 +2426,7 @@
       </p:sp>
       <p:pic>
         <p:nvPicPr>
-          <p:cNvPr id="5" name="slide1-image" descr="C:\Users\NYUAD\AppData\Local\Temp\claude\C--Users-NYUAD-Downloads-FinTechaton\ea8358ed-f283-4dea-9090-adc4a48a45d2\scratchpad\deck\01-home-desktop.png">    </p:cNvPr>
+          <p:cNvPr id="5" name="slide1-image" descr="EgoQuant title image">    </p:cNvPr>
           <p:cNvPicPr>
             <a:picLocks noChangeAspect="1"/>
           </p:cNvPicPr>
@@ -3294,7 +3294,7 @@
       </p:sp>
       <p:pic>
         <p:nvPicPr>
-          <p:cNvPr id="4" name="slide11-image" descr="C:\Users\NYUAD\AppData\Local\Temp\claude\C--Users-NYUAD-Downloads-FinTechaton\ea8358ed-f283-4dea-9090-adc4a48a45d2\scratchpad\deck\10-verify-proof-desktop.png">    </p:cNvPr>
+          <p:cNvPr id="4" name="slide11-image" descr="EgoQuant: Tamper-evident advice: the on-chain seal">    </p:cNvPr>
           <p:cNvPicPr>
             <a:picLocks noChangeAspect="1"/>
           </p:cNvPicPr>
@@ -5472,7 +5472,7 @@
       </p:sp>
       <p:pic>
         <p:nvPicPr>
-          <p:cNvPr id="3" name="slide4-img0" descr="C:\Users\NYUAD\AppData\Local\Temp\claude\C--Users-NYUAD-Downloads-FinTechaton\ea8358ed-f283-4dea-9090-adc4a48a45d2\scratchpad\deck\02-questionnaire-phone.png">    </p:cNvPr>
+          <p:cNvPr id="3" name="slide4-img0" descr="EgoQuant: The journey: about ten minutes, five steps">    </p:cNvPr>
           <p:cNvPicPr>
             <a:picLocks noChangeAspect="1"/>
           </p:cNvPicPr>
@@ -5571,7 +5571,7 @@
       </p:sp>
       <p:pic>
         <p:nvPicPr>
-          <p:cNvPr id="6" name="slide4-img1" descr="C:\Users\NYUAD\AppData\Local\Temp\claude\C--Users-NYUAD-Downloads-FinTechaton\ea8358ed-f283-4dea-9090-adc4a48a45d2\scratchpad\deck\03-game-result-phone.png">    </p:cNvPr>
+          <p:cNvPr id="6" name="slide4-img1" descr="EgoQuant: The journey: about ten minutes, five steps">    </p:cNvPr>
           <p:cNvPicPr>
             <a:picLocks noChangeAspect="1"/>
           </p:cNvPicPr>
@@ -5670,7 +5670,7 @@
       </p:sp>
       <p:pic>
         <p:nvPicPr>
-          <p:cNvPr id="9" name="slide4-img2" descr="C:\Users\NYUAD\AppData\Local\Temp\claude\C--Users-NYUAD-Downloads-FinTechaton\ea8358ed-f283-4dea-9090-adc4a48a45d2\scratchpad\deck\04-interests-counter-phone.png">    </p:cNvPr>
+          <p:cNvPr id="9" name="slide4-img2" descr="EgoQuant: The journey: about ten minutes, five steps">    </p:cNvPr>
           <p:cNvPicPr>
             <a:picLocks noChangeAspect="1"/>
           </p:cNvPicPr>
@@ -5769,7 +5769,7 @@
       </p:sp>
       <p:pic>
         <p:nvPicPr>
-          <p:cNvPr id="12" name="slide4-img3" descr="C:\Users\NYUAD\AppData\Local\Temp\claude\C--Users-NYUAD-Downloads-FinTechaton\ea8358ed-f283-4dea-9090-adc4a48a45d2\scratchpad\deck\05-portfolio-summary-phone.png">    </p:cNvPr>
+          <p:cNvPr id="12" name="slide4-img3" descr="EgoQuant: The journey: about ten minutes, five steps">    </p:cNvPr>
           <p:cNvPicPr>
             <a:picLocks noChangeAspect="1"/>
           </p:cNvPicPr>
@@ -5868,7 +5868,7 @@
       </p:sp>
       <p:pic>
         <p:nvPicPr>
-          <p:cNvPr id="15" name="slide4-img4" descr="C:\Users\NYUAD\AppData\Local\Temp\claude\C--Users-NYUAD-Downloads-FinTechaton\ea8358ed-f283-4dea-9090-adc4a48a45d2\scratchpad\deck\10-verify-proof-phone.png">    </p:cNvPr>
+          <p:cNvPr id="15" name="slide4-img4" descr="EgoQuant: The journey: about ten minutes, five steps">    </p:cNvPr>
           <p:cNvPicPr>
             <a:picLocks noChangeAspect="1"/>
           </p:cNvPicPr>
@@ -9095,7 +9095,7 @@
       </p:sp>
       <p:pic>
         <p:nvPicPr>
-          <p:cNvPr id="4" name="slide7-image" descr="C:\Users\NYUAD\AppData\Local\Temp\claude\C--Users-NYUAD-Downloads-FinTechaton\ea8358ed-f283-4dea-9090-adc4a48a45d2\scratchpad\deck\11-limits-tab-desktop.png">    </p:cNvPr>
+          <p:cNvPr id="4" name="slide7-image" descr="EgoQuant: Behaviour counts, and can only make it safer">    </p:cNvPr>
           <p:cNvPicPr>
             <a:picLocks noChangeAspect="1"/>
           </p:cNvPicPr>
@@ -9375,7 +9375,7 @@
       </p:sp>
       <p:pic>
         <p:nvPicPr>
-          <p:cNvPr id="4" name="slide8-image" descr="C:\Users\NYUAD\AppData\Local\Temp\claude\C--Users-NYUAD-Downloads-FinTechaton\ea8358ed-f283-4dea-9090-adc4a48a45d2\scratchpad\deck\06-goal-tab-desktop.png">    </p:cNvPr>
+          <p:cNvPr id="4" name="slide8-image" descr="EgoQuant: A goal simulation that is honest about history">    </p:cNvPr>
           <p:cNvPicPr>
             <a:picLocks noChangeAspect="1"/>
           </p:cNvPicPr>
@@ -9655,7 +9655,7 @@
       </p:sp>
       <p:pic>
         <p:nvPicPr>
-          <p:cNvPr id="4" name="slide9-image" descr="C:\Users\NYUAD\AppData\Local\Temp\claude\C--Users-NYUAD-Downloads-FinTechaton\ea8358ed-f283-4dea-9090-adc4a48a45d2\scratchpad\deck\09-advisor-trade-card-desktop.png">    </p:cNvPr>
+          <p:cNvPr id="4" name="slide9-image" descr="EgoQuant: The advisor can run the engine but cannot decide">    </p:cNvPr>
           <p:cNvPicPr>
             <a:picLocks noChangeAspect="1"/>
           </p:cNvPicPr>

</xml_diff>